<commit_message>
Remove a speaker note that contradicted the previous slide
4 번 슬라이드 노트가 "다중 뷰 융합은 아직 재 보지 않았습니다" 로 끝나는데,
3 번 슬라이드에서 이미 "후보를 121 쌍까지 늘리고 전부 융합해도 47% 에서
멈춘다" 고 발표한다. 재 본 것을 안 재봤다고 말하는 셈이라 발표 중에 바로
드러난다.

아직 안 해 본 것으로 바꿨다. 스테레오와 카빙을 화소 단위로 융합하는 것이다.
지금은 두 점구름을 그냥 겹쳐 97.7% 를 얻지만 정밀도가 92.9 에서 84.4% 로
떨어진다. 카빙이 만든 껍질 안쪽으로 스테레오 깊이를 밀어 넣어 오목한 부분만
파는 방식이 표준이고, 그러면 둘의 장점만 취할 수 있다. README 9-2 절에 적어 둔
것과 같은 내용이다.

Co-Authored-By: Claude Opus 5 (1M context) <noreply@anthropic.com>
Claude-Session: https://claude.ai/code/session_018U3AzX4tcWGeaMbFnbomri
</commit_message>
<xml_diff>
--- a/02_2d_to_3d/report/2차업무_정승원.pptx
+++ b/02_2d_to_3d/report/2차업무_정승원.pptx
@@ -976,17 +976,27 @@
           <a:p/>
           <a:p>
             <a:r>
-              <a:t>두 번째는 다중 뷰 융합입니다. 지금은 한 쌍만 씁니다. 쓸 만한 쌍이 5개 있으니</a:t>
-            </a:r>
-          </a:p>
-          <a:p>
-            <a:r>
-              <a:t>여러 쌍의 깊이를 합치면 한 쌍에서 비는 부분을 다른 쌍이 채웁니다. 지금 구조에서 가장</a:t>
-            </a:r>
-          </a:p>
-          <a:p>
-            <a:r>
-              <a:t>싸게 얻을 수 있는 개선이라고 봅니다. 이건 아직 재 보지 않았습니다.</a:t>
+              <a:t>두 번째로 아직 안 해 본 것은 스테레오와 카빙을 화소 단위로 합치는 것입니다. 지금은</a:t>
+            </a:r>
+          </a:p>
+          <a:p>
+            <a:r>
+              <a:t>두 점구름을 그냥 겹쳐 98퍼센트를 얻는데, 정밀도가 93에서</a:t>
+            </a:r>
+          </a:p>
+          <a:p>
+            <a:r>
+              <a:t>84퍼센트로 떨어집니다. 카빙이 만든 껍질 안쪽으로 스테레오 깊이를 밀어 넣어</a:t>
+            </a:r>
+          </a:p>
+          <a:p>
+            <a:r>
+              <a:t>오목한 부분만 파는 방식이 표준인데, 그러면 둘의 장점만 취할 수 있습니다. 이건</a:t>
+            </a:r>
+          </a:p>
+          <a:p>
+            <a:r>
+              <a:t>재 보지 않았습니다.</a:t>
             </a:r>
           </a:p>
           <a:p/>

</xml_diff>

<commit_message>
Crop slide figures to the aspect of the space they go into
발표자료 그림을 실제로 눈으로 보고 나온 수정이다. 지금까지 수치만 기계 대조하고
그림은 한 번도 열어 보지 않았다.

crop_box 가 마스크를 정사각으로 잘랐다. 물체마다 생김새가 달라서 이게 안 맞는다.
합성 위성은 태양전지판 때문에 가로가 세로의 세 배쯤이라 정사각으로 자르면 위아래가
비고, SPE3R aqua 는 반대로 세로가 길어 좌우가 빈다. 어느 쪽이든 슬라이드에서
물체가 작아진다.

가로세로를 각각 물체에 맞추고, 슬라이드용 3패널은 그림 자리 비율(1.35:1)에 맞춰
짧은 쪽만 늘린다. 늘리기만 하므로 물체가 잘리지는 않는다. 상세 6패널은 물체에
바싹 붙인 크롭 그대로 둔다.

컬러바도 고쳤다. 축 상자보다 길어져 어색했는데, make_axes_locatable 로 이미지
높이에 붙였다.

  슬라이드 3 그림   6.23 x 2.25 in (카드 46%)  ->  11.13 x 2.86 in (카드 85%)
  슬라이드 2 그림   6.78 x 2.45 in (카드 51%)  ->  11.11 x 2.86 in (카드 85%)

Unit Test 80 개 통과. README 4 건 · PPT 3 건 대조 (불일치 0 건).

Co-Authored-By: Claude Opus 5 (1M context) <noreply@anthropic.com>
Claude-Session: https://claude.ai/code/session_018U3AzX4tcWGeaMbFnbomri
</commit_message>
<xml_diff>
--- a/02_2d_to_3d/report/2차업무_정승원.pptx
+++ b/02_2d_to_3d/report/2차업무_정승원.pptx
@@ -5118,8 +5118,8 @@
         </p:blipFill>
         <p:spPr>
           <a:xfrm>
-            <a:off x="1416258" y="1691639"/>
-            <a:ext cx="9356435" cy="2615184"/>
+            <a:off x="1013832" y="1691639"/>
+            <a:ext cx="10161287" cy="2615184"/>
           </a:xfrm>
           <a:prstGeom prst="rect">
             <a:avLst/>

</xml_diff>